<commit_message>
feat: redesign architecture slide with proper shapes, arrows, and color-coded cards
Co-Authored-By: Claude Opus 4.7 <noreply@anthropic.com>
</commit_message>
<xml_diff>
--- a/docs/claude-lab-showcase.pptx
+++ b/docs/claude-lab-showcase.pptx
@@ -6892,14 +6892,14 @@
         </p:nvSpPr>
         <p:spPr>
           <a:xfrm>
-            <a:off x="1371600" y="1188720"/>
-            <a:ext cx="9144000" cy="5029200"/>
+            <a:off x="3718407" y="1097280"/>
+            <a:ext cx="4754880" cy="1463039"/>
           </a:xfrm>
           <a:prstGeom prst="roundRect">
             <a:avLst/>
           </a:prstGeom>
           <a:solidFill>
-            <a:srgbClr val="161B22"/>
+            <a:srgbClr val="1A3A5C"/>
           </a:solidFill>
           <a:ln>
             <a:noFill/>
@@ -6929,14 +6929,696 @@
       </p:sp>
       <p:sp>
         <p:nvSpPr>
-          <p:cNvPr id="5" name="TextBox 4"/>
+          <p:cNvPr id="5" name="Rounded Rectangle 4"/>
+          <p:cNvSpPr/>
+          <p:nvPr/>
+        </p:nvSpPr>
+        <p:spPr>
+          <a:xfrm>
+            <a:off x="3809847" y="1188720"/>
+            <a:ext cx="4572000" cy="1280160"/>
+          </a:xfrm>
+          <a:prstGeom prst="roundRect">
+            <a:avLst/>
+          </a:prstGeom>
+          <a:solidFill>
+            <a:srgbClr val="161B22"/>
+          </a:solidFill>
+          <a:ln w="19050">
+            <a:solidFill>
+              <a:srgbClr val="3B82F6"/>
+            </a:solidFill>
+          </a:ln>
+        </p:spPr>
+        <p:style>
+          <a:lnRef idx="1">
+            <a:schemeClr val="accent1"/>
+          </a:lnRef>
+          <a:fillRef idx="3">
+            <a:schemeClr val="accent1"/>
+          </a:fillRef>
+          <a:effectRef idx="2">
+            <a:schemeClr val="accent1"/>
+          </a:effectRef>
+          <a:fontRef idx="minor">
+            <a:schemeClr val="lt1"/>
+          </a:fontRef>
+        </p:style>
+        <p:txBody>
+          <a:bodyPr rtlCol="0" anchor="ctr" wrap="square"/>
+          <a:lstStyle/>
+          <a:p>
+            <a:pPr algn="ctr">
+              <a:defRPr sz="2600" b="1">
+                <a:solidFill>
+                  <a:srgbClr val="FFFFFF"/>
+                </a:solidFill>
+                <a:latin typeface="Microsoft YaHei"/>
+              </a:defRPr>
+            </a:pPr>
+            <a:r>
+              <a:t>Claude Code CLI</a:t>
+            </a:r>
+          </a:p>
+          <a:p>
+            <a:pPr algn="ctr">
+              <a:defRPr sz="1400">
+                <a:solidFill>
+                  <a:srgbClr val="3B82F6"/>
+                </a:solidFill>
+                <a:latin typeface="Microsoft YaHei"/>
+              </a:defRPr>
+            </a:pPr>
+            <a:r>
+              <a:t>DeepSeek V4 Pro  (Anthropic API 协议)</a:t>
+            </a:r>
+          </a:p>
+        </p:txBody>
+      </p:sp>
+      <p:sp>
+        <p:nvSpPr>
+          <p:cNvPr id="6" name="Down Arrow 5"/>
+          <p:cNvSpPr/>
+          <p:nvPr/>
+        </p:nvSpPr>
+        <p:spPr>
+          <a:xfrm>
+            <a:off x="5958687" y="2560320"/>
+            <a:ext cx="274320" cy="457200"/>
+          </a:xfrm>
+          <a:prstGeom prst="downArrow">
+            <a:avLst/>
+          </a:prstGeom>
+          <a:solidFill>
+            <a:srgbClr val="3B82F6"/>
+          </a:solidFill>
+          <a:ln>
+            <a:noFill/>
+          </a:ln>
+        </p:spPr>
+        <p:style>
+          <a:lnRef idx="1">
+            <a:schemeClr val="accent1"/>
+          </a:lnRef>
+          <a:fillRef idx="3">
+            <a:schemeClr val="accent1"/>
+          </a:fillRef>
+          <a:effectRef idx="2">
+            <a:schemeClr val="accent1"/>
+          </a:effectRef>
+          <a:fontRef idx="minor">
+            <a:schemeClr val="lt1"/>
+          </a:fontRef>
+        </p:style>
+        <p:txBody>
+          <a:bodyPr rtlCol="0" anchor="ctr"/>
+          <a:lstStyle/>
+          <a:p>
+            <a:pPr algn="ctr"/>
+          </a:p>
+        </p:txBody>
+      </p:sp>
+      <p:sp>
+        <p:nvSpPr>
+          <p:cNvPr id="7" name="Rounded Rectangle 6"/>
+          <p:cNvSpPr/>
+          <p:nvPr/>
+        </p:nvSpPr>
+        <p:spPr>
+          <a:xfrm>
+            <a:off x="678027" y="3108960"/>
+            <a:ext cx="2468880" cy="1645920"/>
+          </a:xfrm>
+          <a:prstGeom prst="roundRect">
+            <a:avLst/>
+          </a:prstGeom>
+          <a:solidFill>
+            <a:srgbClr val="161B22"/>
+          </a:solidFill>
+          <a:ln w="12700">
+            <a:solidFill>
+              <a:srgbClr val="3B82F6"/>
+            </a:solidFill>
+          </a:ln>
+        </p:spPr>
+        <p:style>
+          <a:lnRef idx="1">
+            <a:schemeClr val="accent1"/>
+          </a:lnRef>
+          <a:fillRef idx="3">
+            <a:schemeClr val="accent1"/>
+          </a:fillRef>
+          <a:effectRef idx="2">
+            <a:schemeClr val="accent1"/>
+          </a:effectRef>
+          <a:fontRef idx="minor">
+            <a:schemeClr val="lt1"/>
+          </a:fontRef>
+        </p:style>
+        <p:txBody>
+          <a:bodyPr rtlCol="0" anchor="ctr" wrap="square"/>
+          <a:lstStyle/>
+          <a:p>
+            <a:pPr algn="ctr">
+              <a:defRPr sz="1600" b="1">
+                <a:solidFill>
+                  <a:srgbClr val="3B82F6"/>
+                </a:solidFill>
+                <a:latin typeface="Consolas"/>
+              </a:defRPr>
+            </a:pPr>
+            <a:r>
+              <a:t>👁️  v.py</a:t>
+            </a:r>
+          </a:p>
+          <a:p>
+            <a:pPr algn="ctr">
+              <a:defRPr sz="1200">
+                <a:solidFill>
+                  <a:srgbClr val="9CA3AF"/>
+                </a:solidFill>
+                <a:latin typeface="Microsoft YaHei"/>
+              </a:defRPr>
+            </a:pPr>
+            <a:r>
+              <a:t>Gemini + GPT-4o</a:t>
+            </a:r>
+            <a:br/>
+            <a:r>
+              <a:t>双引擎驱动</a:t>
+            </a:r>
+          </a:p>
+        </p:txBody>
+      </p:sp>
+      <p:sp>
+        <p:nvSpPr>
+          <p:cNvPr id="8" name="Rectangle 7"/>
+          <p:cNvSpPr/>
+          <p:nvPr/>
+        </p:nvSpPr>
+        <p:spPr>
+          <a:xfrm>
+            <a:off x="678027" y="3108960"/>
+            <a:ext cx="2468880" cy="45720"/>
+          </a:xfrm>
+          <a:prstGeom prst="rect">
+            <a:avLst/>
+          </a:prstGeom>
+          <a:solidFill>
+            <a:srgbClr val="3B82F6"/>
+          </a:solidFill>
+          <a:ln>
+            <a:noFill/>
+          </a:ln>
+        </p:spPr>
+        <p:style>
+          <a:lnRef idx="1">
+            <a:schemeClr val="accent1"/>
+          </a:lnRef>
+          <a:fillRef idx="3">
+            <a:schemeClr val="accent1"/>
+          </a:fillRef>
+          <a:effectRef idx="2">
+            <a:schemeClr val="accent1"/>
+          </a:effectRef>
+          <a:fontRef idx="minor">
+            <a:schemeClr val="lt1"/>
+          </a:fontRef>
+        </p:style>
+        <p:txBody>
+          <a:bodyPr rtlCol="0" anchor="ctr"/>
+          <a:lstStyle/>
+          <a:p>
+            <a:pPr algn="ctr"/>
+          </a:p>
+        </p:txBody>
+      </p:sp>
+      <p:sp>
+        <p:nvSpPr>
+          <p:cNvPr id="9" name="Rounded Rectangle 8"/>
+          <p:cNvSpPr/>
+          <p:nvPr/>
+        </p:nvSpPr>
+        <p:spPr>
+          <a:xfrm>
+            <a:off x="3466947" y="3108960"/>
+            <a:ext cx="2468880" cy="1645920"/>
+          </a:xfrm>
+          <a:prstGeom prst="roundRect">
+            <a:avLst/>
+          </a:prstGeom>
+          <a:solidFill>
+            <a:srgbClr val="161B22"/>
+          </a:solidFill>
+          <a:ln w="12700">
+            <a:solidFill>
+              <a:srgbClr val="10B981"/>
+            </a:solidFill>
+          </a:ln>
+        </p:spPr>
+        <p:style>
+          <a:lnRef idx="1">
+            <a:schemeClr val="accent1"/>
+          </a:lnRef>
+          <a:fillRef idx="3">
+            <a:schemeClr val="accent1"/>
+          </a:fillRef>
+          <a:effectRef idx="2">
+            <a:schemeClr val="accent1"/>
+          </a:effectRef>
+          <a:fontRef idx="minor">
+            <a:schemeClr val="lt1"/>
+          </a:fontRef>
+        </p:style>
+        <p:txBody>
+          <a:bodyPr rtlCol="0" anchor="ctr" wrap="square"/>
+          <a:lstStyle/>
+          <a:p>
+            <a:pPr algn="ctr">
+              <a:defRPr sz="1600" b="1">
+                <a:solidFill>
+                  <a:srgbClr val="10B981"/>
+                </a:solidFill>
+                <a:latin typeface="Consolas"/>
+              </a:defRPr>
+            </a:pPr>
+            <a:r>
+              <a:t>🎨  generate_art.py</a:t>
+            </a:r>
+          </a:p>
+          <a:p>
+            <a:pPr algn="ctr">
+              <a:defRPr sz="1200">
+                <a:solidFill>
+                  <a:srgbClr val="9CA3AF"/>
+                </a:solidFill>
+                <a:latin typeface="Microsoft YaHei"/>
+              </a:defRPr>
+            </a:pPr>
+            <a:r>
+              <a:t>Flux → Turbo</a:t>
+            </a:r>
+            <a:br/>
+            <a:r>
+              <a:t>→ Standard 流水线</a:t>
+            </a:r>
+          </a:p>
+        </p:txBody>
+      </p:sp>
+      <p:sp>
+        <p:nvSpPr>
+          <p:cNvPr id="10" name="Rectangle 9"/>
+          <p:cNvSpPr/>
+          <p:nvPr/>
+        </p:nvSpPr>
+        <p:spPr>
+          <a:xfrm>
+            <a:off x="3466947" y="3108960"/>
+            <a:ext cx="2468880" cy="45720"/>
+          </a:xfrm>
+          <a:prstGeom prst="rect">
+            <a:avLst/>
+          </a:prstGeom>
+          <a:solidFill>
+            <a:srgbClr val="10B981"/>
+          </a:solidFill>
+          <a:ln>
+            <a:noFill/>
+          </a:ln>
+        </p:spPr>
+        <p:style>
+          <a:lnRef idx="1">
+            <a:schemeClr val="accent1"/>
+          </a:lnRef>
+          <a:fillRef idx="3">
+            <a:schemeClr val="accent1"/>
+          </a:fillRef>
+          <a:effectRef idx="2">
+            <a:schemeClr val="accent1"/>
+          </a:effectRef>
+          <a:fontRef idx="minor">
+            <a:schemeClr val="lt1"/>
+          </a:fontRef>
+        </p:style>
+        <p:txBody>
+          <a:bodyPr rtlCol="0" anchor="ctr"/>
+          <a:lstStyle/>
+          <a:p>
+            <a:pPr algn="ctr"/>
+          </a:p>
+        </p:txBody>
+      </p:sp>
+      <p:sp>
+        <p:nvSpPr>
+          <p:cNvPr id="11" name="Rounded Rectangle 10"/>
+          <p:cNvSpPr/>
+          <p:nvPr/>
+        </p:nvSpPr>
+        <p:spPr>
+          <a:xfrm>
+            <a:off x="6255867" y="3108960"/>
+            <a:ext cx="2468880" cy="1645920"/>
+          </a:xfrm>
+          <a:prstGeom prst="roundRect">
+            <a:avLst/>
+          </a:prstGeom>
+          <a:solidFill>
+            <a:srgbClr val="161B22"/>
+          </a:solidFill>
+          <a:ln w="12700">
+            <a:solidFill>
+              <a:srgbClr val="F59E0B"/>
+            </a:solidFill>
+          </a:ln>
+        </p:spPr>
+        <p:style>
+          <a:lnRef idx="1">
+            <a:schemeClr val="accent1"/>
+          </a:lnRef>
+          <a:fillRef idx="3">
+            <a:schemeClr val="accent1"/>
+          </a:fillRef>
+          <a:effectRef idx="2">
+            <a:schemeClr val="accent1"/>
+          </a:effectRef>
+          <a:fontRef idx="minor">
+            <a:schemeClr val="lt1"/>
+          </a:fontRef>
+        </p:style>
+        <p:txBody>
+          <a:bodyPr rtlCol="0" anchor="ctr" wrap="square"/>
+          <a:lstStyle/>
+          <a:p>
+            <a:pPr algn="ctr">
+              <a:defRPr sz="1600" b="1">
+                <a:solidFill>
+                  <a:srgbClr val="F59E0B"/>
+                </a:solidFill>
+                <a:latin typeface="Consolas"/>
+              </a:defRPr>
+            </a:pPr>
+            <a:r>
+              <a:t>🌐  fetch.py</a:t>
+            </a:r>
+          </a:p>
+          <a:p>
+            <a:pPr algn="ctr">
+              <a:defRPr sz="1200">
+                <a:solidFill>
+                  <a:srgbClr val="9CA3AF"/>
+                </a:solidFill>
+                <a:latin typeface="Microsoft YaHei"/>
+              </a:defRPr>
+            </a:pPr>
+            <a:r>
+              <a:t>零依赖</a:t>
+            </a:r>
+            <a:br/>
+            <a:r>
+              <a:t>Python 标准库</a:t>
+            </a:r>
+          </a:p>
+        </p:txBody>
+      </p:sp>
+      <p:sp>
+        <p:nvSpPr>
+          <p:cNvPr id="12" name="Rectangle 11"/>
+          <p:cNvSpPr/>
+          <p:nvPr/>
+        </p:nvSpPr>
+        <p:spPr>
+          <a:xfrm>
+            <a:off x="6255867" y="3108960"/>
+            <a:ext cx="2468880" cy="45720"/>
+          </a:xfrm>
+          <a:prstGeom prst="rect">
+            <a:avLst/>
+          </a:prstGeom>
+          <a:solidFill>
+            <a:srgbClr val="F59E0B"/>
+          </a:solidFill>
+          <a:ln>
+            <a:noFill/>
+          </a:ln>
+        </p:spPr>
+        <p:style>
+          <a:lnRef idx="1">
+            <a:schemeClr val="accent1"/>
+          </a:lnRef>
+          <a:fillRef idx="3">
+            <a:schemeClr val="accent1"/>
+          </a:fillRef>
+          <a:effectRef idx="2">
+            <a:schemeClr val="accent1"/>
+          </a:effectRef>
+          <a:fontRef idx="minor">
+            <a:schemeClr val="lt1"/>
+          </a:fontRef>
+        </p:style>
+        <p:txBody>
+          <a:bodyPr rtlCol="0" anchor="ctr"/>
+          <a:lstStyle/>
+          <a:p>
+            <a:pPr algn="ctr"/>
+          </a:p>
+        </p:txBody>
+      </p:sp>
+      <p:sp>
+        <p:nvSpPr>
+          <p:cNvPr id="13" name="Rounded Rectangle 12"/>
+          <p:cNvSpPr/>
+          <p:nvPr/>
+        </p:nvSpPr>
+        <p:spPr>
+          <a:xfrm>
+            <a:off x="9044787" y="3108960"/>
+            <a:ext cx="2468880" cy="1645920"/>
+          </a:xfrm>
+          <a:prstGeom prst="roundRect">
+            <a:avLst/>
+          </a:prstGeom>
+          <a:solidFill>
+            <a:srgbClr val="161B22"/>
+          </a:solidFill>
+          <a:ln w="12700">
+            <a:solidFill>
+              <a:srgbClr val="A855F7"/>
+            </a:solidFill>
+          </a:ln>
+        </p:spPr>
+        <p:style>
+          <a:lnRef idx="1">
+            <a:schemeClr val="accent1"/>
+          </a:lnRef>
+          <a:fillRef idx="3">
+            <a:schemeClr val="accent1"/>
+          </a:fillRef>
+          <a:effectRef idx="2">
+            <a:schemeClr val="accent1"/>
+          </a:effectRef>
+          <a:fontRef idx="minor">
+            <a:schemeClr val="lt1"/>
+          </a:fontRef>
+        </p:style>
+        <p:txBody>
+          <a:bodyPr rtlCol="0" anchor="ctr" wrap="square"/>
+          <a:lstStyle/>
+          <a:p>
+            <a:pPr algn="ctr">
+              <a:defRPr sz="1600" b="1">
+                <a:solidFill>
+                  <a:srgbClr val="A855F7"/>
+                </a:solidFill>
+                <a:latin typeface="Consolas"/>
+              </a:defRPr>
+            </a:pPr>
+            <a:r>
+              <a:t>📊  plot_sine.py</a:t>
+            </a:r>
+          </a:p>
+          <a:p>
+            <a:pPr algn="ctr">
+              <a:defRPr sz="1200">
+                <a:solidFill>
+                  <a:srgbClr val="9CA3AF"/>
+                </a:solidFill>
+                <a:latin typeface="Microsoft YaHei"/>
+              </a:defRPr>
+            </a:pPr>
+            <a:r>
+              <a:t>Matplotlib</a:t>
+            </a:r>
+            <a:br/>
+            <a:r>
+              <a:t>图表生成</a:t>
+            </a:r>
+          </a:p>
+        </p:txBody>
+      </p:sp>
+      <p:sp>
+        <p:nvSpPr>
+          <p:cNvPr id="14" name="Rectangle 13"/>
+          <p:cNvSpPr/>
+          <p:nvPr/>
+        </p:nvSpPr>
+        <p:spPr>
+          <a:xfrm>
+            <a:off x="9044787" y="3108960"/>
+            <a:ext cx="2468880" cy="45720"/>
+          </a:xfrm>
+          <a:prstGeom prst="rect">
+            <a:avLst/>
+          </a:prstGeom>
+          <a:solidFill>
+            <a:srgbClr val="A855F7"/>
+          </a:solidFill>
+          <a:ln>
+            <a:noFill/>
+          </a:ln>
+        </p:spPr>
+        <p:style>
+          <a:lnRef idx="1">
+            <a:schemeClr val="accent1"/>
+          </a:lnRef>
+          <a:fillRef idx="3">
+            <a:schemeClr val="accent1"/>
+          </a:fillRef>
+          <a:effectRef idx="2">
+            <a:schemeClr val="accent1"/>
+          </a:effectRef>
+          <a:fontRef idx="minor">
+            <a:schemeClr val="lt1"/>
+          </a:fontRef>
+        </p:style>
+        <p:txBody>
+          <a:bodyPr rtlCol="0" anchor="ctr"/>
+          <a:lstStyle/>
+          <a:p>
+            <a:pPr algn="ctr"/>
+          </a:p>
+        </p:txBody>
+      </p:sp>
+      <p:sp>
+        <p:nvSpPr>
+          <p:cNvPr id="15" name="Down Arrow 14"/>
+          <p:cNvSpPr/>
+          <p:nvPr/>
+        </p:nvSpPr>
+        <p:spPr>
+          <a:xfrm>
+            <a:off x="5958687" y="4846320"/>
+            <a:ext cx="274320" cy="365760"/>
+          </a:xfrm>
+          <a:prstGeom prst="downArrow">
+            <a:avLst/>
+          </a:prstGeom>
+          <a:solidFill>
+            <a:srgbClr val="10B981"/>
+          </a:solidFill>
+          <a:ln>
+            <a:noFill/>
+          </a:ln>
+        </p:spPr>
+        <p:style>
+          <a:lnRef idx="1">
+            <a:schemeClr val="accent1"/>
+          </a:lnRef>
+          <a:fillRef idx="3">
+            <a:schemeClr val="accent1"/>
+          </a:fillRef>
+          <a:effectRef idx="2">
+            <a:schemeClr val="accent1"/>
+          </a:effectRef>
+          <a:fontRef idx="minor">
+            <a:schemeClr val="lt1"/>
+          </a:fontRef>
+        </p:style>
+        <p:txBody>
+          <a:bodyPr rtlCol="0" anchor="ctr"/>
+          <a:lstStyle/>
+          <a:p>
+            <a:pPr algn="ctr"/>
+          </a:p>
+        </p:txBody>
+      </p:sp>
+      <p:sp>
+        <p:nvSpPr>
+          <p:cNvPr id="16" name="Rounded Rectangle 15"/>
+          <p:cNvSpPr/>
+          <p:nvPr/>
+        </p:nvSpPr>
+        <p:spPr>
+          <a:xfrm>
+            <a:off x="2895447" y="5394960"/>
+            <a:ext cx="6400800" cy="914400"/>
+          </a:xfrm>
+          <a:prstGeom prst="roundRect">
+            <a:avLst/>
+          </a:prstGeom>
+          <a:solidFill>
+            <a:srgbClr val="161B22"/>
+          </a:solidFill>
+          <a:ln w="12700">
+            <a:solidFill>
+              <a:srgbClr val="10B981"/>
+            </a:solidFill>
+          </a:ln>
+        </p:spPr>
+        <p:style>
+          <a:lnRef idx="1">
+            <a:schemeClr val="accent1"/>
+          </a:lnRef>
+          <a:fillRef idx="3">
+            <a:schemeClr val="accent1"/>
+          </a:fillRef>
+          <a:effectRef idx="2">
+            <a:schemeClr val="accent1"/>
+          </a:effectRef>
+          <a:fontRef idx="minor">
+            <a:schemeClr val="lt1"/>
+          </a:fontRef>
+        </p:style>
+        <p:txBody>
+          <a:bodyPr rtlCol="0" anchor="ctr" wrap="square"/>
+          <a:lstStyle/>
+          <a:p>
+            <a:pPr algn="ctr">
+              <a:defRPr sz="1800" b="1">
+                <a:solidFill>
+                  <a:srgbClr val="FFFFFF"/>
+                </a:solidFill>
+                <a:latin typeface="Microsoft YaHei"/>
+              </a:defRPr>
+            </a:pPr>
+            <a:r>
+              <a:t>🧠  memory/  —  持久记忆系统</a:t>
+            </a:r>
+          </a:p>
+          <a:p>
+            <a:pPr algn="ctr">
+              <a:defRPr sz="1300">
+                <a:solidFill>
+                  <a:srgbClr val="9CA3AF"/>
+                </a:solidFill>
+                <a:latin typeface="Microsoft YaHei"/>
+              </a:defRPr>
+            </a:pPr>
+            <a:r>
+              <a:t>rules.md (偏好)  ·  context.md (会话)  ·  MEMORY.md (索引)  —  关了重开，什么都记得</a:t>
+            </a:r>
+          </a:p>
+        </p:txBody>
+      </p:sp>
+      <p:sp>
+        <p:nvSpPr>
+          <p:cNvPr id="17" name="TextBox 16"/>
           <p:cNvSpPr txBox="1"/>
           <p:nvPr/>
         </p:nvSpPr>
         <p:spPr>
           <a:xfrm>
-            <a:off x="2011680" y="1463040"/>
-            <a:ext cx="7772400" cy="4572000"/>
+            <a:off x="731520" y="6217920"/>
+            <a:ext cx="10972800" cy="365760"/>
           </a:xfrm>
           <a:prstGeom prst="rect">
             <a:avLst/>
@@ -6949,104 +7631,16 @@
           </a:bodyPr>
           <a:lstStyle/>
           <a:p>
-            <a:pPr algn="l">
-              <a:defRPr sz="1500" b="0">
-                <a:solidFill>
-                  <a:srgbClr val="FFFFFF"/>
-                </a:solidFill>
-                <a:latin typeface="Consolas"/>
-              </a:defRPr>
-            </a:pPr>
-            <a:r>
-              <a:t>┌─────────────────────────────────────────┐</a:t>
-            </a:r>
-            <a:br/>
-            <a:r>
-              <a:t>│          Claude Code CLI                  │</a:t>
-            </a:r>
-            <a:br/>
-            <a:r>
-              <a:t>│    ←  DeepSeek V4 Pro (Anthropic API)    │</a:t>
-            </a:r>
-            <a:br/>
-            <a:r>
-              <a:t>├─────────────────────────────────────────┤</a:t>
-            </a:r>
-            <a:br/>
-            <a:r>
-              <a:t>│                                           │</a:t>
-            </a:r>
-            <a:br/>
-            <a:r>
-              <a:t>│  📁 tools/                                │</a:t>
-            </a:r>
-            <a:br/>
-            <a:r>
-              <a:t>│   ├─ v.py              视觉网关           │</a:t>
-            </a:r>
-            <a:br/>
-            <a:r>
-              <a:t>│   │   Gemini Flash + GPT-4o 双引擎       │</a:t>
-            </a:r>
-            <a:br/>
-            <a:r>
-              <a:t>│   │                                       │</a:t>
-            </a:r>
-            <a:br/>
-            <a:r>
-              <a:t>│   ├─ generate_art.py   AI 绘画            │</a:t>
-            </a:r>
-            <a:br/>
-            <a:r>
-              <a:t>│   │   Flux → Turbo → Standard 流水线     │</a:t>
-            </a:r>
-            <a:br/>
-            <a:r>
-              <a:t>│   │                                       │</a:t>
-            </a:r>
-            <a:br/>
-            <a:r>
-              <a:t>│   ├─ fetch.py          网页抓取           │</a:t>
-            </a:r>
-            <a:br/>
-            <a:r>
-              <a:t>│   │   零依赖 · Python 标准库              │</a:t>
-            </a:r>
-            <a:br/>
-            <a:r>
-              <a:t>│   │                                       │</a:t>
-            </a:r>
-            <a:br/>
-            <a:r>
-              <a:t>│   └─ plot_sine.py      数据可视化         │</a:t>
-            </a:r>
-            <a:br/>
-            <a:r>
-              <a:t>│                                           │</a:t>
-            </a:r>
-            <a:br/>
-            <a:r>
-              <a:t>│  🧠 memory/             持久记忆          │</a:t>
-            </a:r>
-            <a:br/>
-            <a:r>
-              <a:t>│   ├─ rules.md           用户偏好          │</a:t>
-            </a:r>
-            <a:br/>
-            <a:r>
-              <a:t>│   ├─ context.md         会话上下文        │</a:t>
-            </a:r>
-            <a:br/>
-            <a:r>
-              <a:t>│   └─ MEMORY.md          记忆索引          │</a:t>
-            </a:r>
-            <a:br/>
-            <a:r>
-              <a:t>│                                           │</a:t>
-            </a:r>
-            <a:br/>
-            <a:r>
-              <a:t>└─────────────────────────────────────────┘</a:t>
+            <a:pPr algn="ctr">
+              <a:defRPr sz="1400" b="0">
+                <a:solidFill>
+                  <a:srgbClr val="9CA3AF"/>
+                </a:solidFill>
+                <a:latin typeface="Microsoft YaHei"/>
+              </a:defRPr>
+            </a:pPr>
+            <a:r>
+              <a:t>🆓 全部免费    💰 仅 DeepSeek 付费（≈1元/月）</a:t>
             </a:r>
           </a:p>
         </p:txBody>

</xml_diff>